<commit_message>
Rapor grafikleri + dashboard guncelleme + teslim paketleri
</commit_message>
<xml_diff>
--- a/stage2_gelismis_cozum/teslim/LoadIQ_Sunum.pptx
+++ b/stage2_gelismis_cozum/teslim/LoadIQ_Sunum.pptx
@@ -9076,7 +9076,7 @@
                 <a:ea typeface="Cambria" pitchFamily="34" charset="-122"/>
                 <a:cs typeface="Cambria" pitchFamily="34" charset="-120"/>
               </a:rPr>
-              <a:t>29,84 M TL</a:t>
+              <a:t>21,74 M TL</a:t>
             </a:r>
             <a:endParaRPr lang="en-US" sz="4000" dirty="0"/>
           </a:p>
@@ -9154,7 +9154,7 @@
                 <a:ea typeface="Cambria" pitchFamily="34" charset="-122"/>
                 <a:cs typeface="Cambria" pitchFamily="34" charset="-120"/>
               </a:rPr>
-              <a:t>28,66 M</a:t>
+              <a:t>20,55 M</a:t>
             </a:r>
             <a:endParaRPr lang="en-US" sz="4000" dirty="0"/>
           </a:p>
@@ -9232,7 +9232,7 @@
                 <a:ea typeface="Cambria" pitchFamily="34" charset="-122"/>
                 <a:cs typeface="Cambria" pitchFamily="34" charset="-120"/>
               </a:rPr>
-              <a:t>1,17 M</a:t>
+              <a:t>1,19 M</a:t>
             </a:r>
             <a:endParaRPr lang="en-US" sz="4000" dirty="0"/>
           </a:p>
@@ -9310,7 +9310,7 @@
                 <a:ea typeface="Cambria" pitchFamily="34" charset="-122"/>
                 <a:cs typeface="Cambria" pitchFamily="34" charset="-120"/>
               </a:rPr>
-              <a:t>3.697</a:t>
+              <a:t>1.594</a:t>
             </a:r>
             <a:endParaRPr lang="en-US" sz="4000" dirty="0"/>
           </a:p>
@@ -9349,7 +9349,7 @@
                 <a:ea typeface="Calibri" pitchFamily="34" charset="-122"/>
                 <a:cs typeface="Calibri" pitchFamily="34" charset="-120"/>
               </a:rPr>
-              <a:t>Plan satırı</a:t>
+              <a:t>Araç sayısı</a:t>
             </a:r>
             <a:endParaRPr lang="en-US" sz="1400" dirty="0"/>
           </a:p>
@@ -9388,7 +9388,7 @@
                 <a:ea typeface="Cambria" pitchFamily="34" charset="-122"/>
                 <a:cs typeface="Cambria" pitchFamily="34" charset="-120"/>
               </a:rPr>
-              <a:t>28 / 28</a:t>
+              <a:t>30 / 30</a:t>
             </a:r>
             <a:endParaRPr lang="en-US" sz="4000" dirty="0"/>
           </a:p>
@@ -9566,7 +9566,7 @@
                 <a:ea typeface="Calibri" pitchFamily="34" charset="-122"/>
                 <a:cs typeface="Calibri" pitchFamily="34" charset="-120"/>
               </a:rPr>
-              <a:t>Baseline'a göre:  toplam maliyet −%12,  SLA cezası −%76.  27 boş araç temizlendi (−450 B TL).  Talep %100 taşınıyor, sıfır ihlal.</a:t>
+              <a:t>Konsolidasyonla toplam maliyet 29,84M → 21,74M TL (−%27,1).  Saat birleştirme + milk-run, checker-korumalı.  Talep %100 taşınıyor, sıfır ihlal.</a:t>
             </a:r>
             <a:endParaRPr lang="en-US" sz="1500" dirty="0"/>
           </a:p>

</xml_diff>

<commit_message>
Feasibility fix: check_cikis_hazirlik + akilli kiralik (22.11M feasible, 32/32)
</commit_message>
<xml_diff>
--- a/stage2_gelismis_cozum/teslim/LoadIQ_Sunum.pptx
+++ b/stage2_gelismis_cozum/teslim/LoadIQ_Sunum.pptx
@@ -9076,7 +9076,7 @@
                 <a:ea typeface="Cambria" pitchFamily="34" charset="-122"/>
                 <a:cs typeface="Cambria" pitchFamily="34" charset="-120"/>
               </a:rPr>
-              <a:t>21,74 M TL</a:t>
+              <a:t>22,11 M TL</a:t>
             </a:r>
             <a:endParaRPr lang="en-US" sz="4000" dirty="0"/>
           </a:p>
@@ -9154,7 +9154,7 @@
                 <a:ea typeface="Cambria" pitchFamily="34" charset="-122"/>
                 <a:cs typeface="Cambria" pitchFamily="34" charset="-120"/>
               </a:rPr>
-              <a:t>20,55 M</a:t>
+              <a:t>20,94 M</a:t>
             </a:r>
             <a:endParaRPr lang="en-US" sz="4000" dirty="0"/>
           </a:p>
@@ -9232,7 +9232,7 @@
                 <a:ea typeface="Cambria" pitchFamily="34" charset="-122"/>
                 <a:cs typeface="Cambria" pitchFamily="34" charset="-120"/>
               </a:rPr>
-              <a:t>1,19 M</a:t>
+              <a:t>1,17 M</a:t>
             </a:r>
             <a:endParaRPr lang="en-US" sz="4000" dirty="0"/>
           </a:p>
@@ -9310,7 +9310,7 @@
                 <a:ea typeface="Cambria" pitchFamily="34" charset="-122"/>
                 <a:cs typeface="Cambria" pitchFamily="34" charset="-120"/>
               </a:rPr>
-              <a:t>1.594</a:t>
+              <a:t>1.697</a:t>
             </a:r>
             <a:endParaRPr lang="en-US" sz="4000" dirty="0"/>
           </a:p>
@@ -9388,7 +9388,7 @@
                 <a:ea typeface="Cambria" pitchFamily="34" charset="-122"/>
                 <a:cs typeface="Cambria" pitchFamily="34" charset="-120"/>
               </a:rPr>
-              <a:t>30 / 30</a:t>
+              <a:t>32 / 32</a:t>
             </a:r>
             <a:endParaRPr lang="en-US" sz="4000" dirty="0"/>
           </a:p>
@@ -9558,7 +9558,7 @@
               <a:buNone/>
             </a:pPr>
             <a:r>
-              <a:rPr lang="en-US" sz="1500" b="1" dirty="0">
+              <a:rPr lang="en-US" sz="1400" b="1" dirty="0">
                 <a:solidFill>
                   <a:srgbClr val="FFFFFF"/>
                 </a:solidFill>
@@ -9566,9 +9566,9 @@
                 <a:ea typeface="Calibri" pitchFamily="34" charset="-122"/>
                 <a:cs typeface="Calibri" pitchFamily="34" charset="-120"/>
               </a:rPr>
-              <a:t>Konsolidasyonla toplam maliyet 29,84M → 21,74M TL (−%27,1).  Saat birleştirme + milk-run, checker-korumalı.  Talep %100 taşınıyor, sıfır ihlal.</a:t>
-            </a:r>
-            <a:endParaRPr lang="en-US" sz="1500" dirty="0"/>
+              <a:t>Konsolidasyon + feasibility düzeltmesi: 29,84M → 22,11M TL (−%25,9), TAM FEASIBLE.  Checker-korumalı, %100 talep, sıfır uygunluk ihlali.</a:t>
+            </a:r>
+            <a:endParaRPr lang="en-US" sz="1400" dirty="0"/>
           </a:p>
         </p:txBody>
       </p:sp>

</xml_diff>